<commit_message>
Convergencia hasta 80^3 (CG + pyamg, un proceso por caso) y presentacion actualizada
Co-Authored-By: Claude Sonnet 5.5 <noreply@anthropic.com>
Claude-Session: https://claude.ai/code/session_01MbGpdKPaFadnBNHe8jp7Wt
</commit_message>
<xml_diff>
--- a/comparativa_motores/tapia_c1_c5/Tapia_C1_C5.pptx
+++ b/comparativa_motores/tapia_c1_c5/Tapia_C1_C5.pptx
@@ -121,25 +121,25 @@
   <p:extLst>
     <p:ext uri="{521415D9-36F7-43E2-AB2F-B90AF26B5E84}">
       <p14:sectionLst xmlns:p14="http://schemas.microsoft.com/office/powerpoint/2010/main">
-        <p14:section name="Apertura" id="{a7a1f8ea-65dc-15de-8a7b-459a16700fa1}">
+        <p14:section name="Apertura" id="{c959f835-10c0-07b2-b50c-44d7300f80d1}">
           <p14:sldIdLst>
             <p14:sldId id="256"/>
           </p14:sldIdLst>
         </p14:section>
-        <p14:section name="Experimento y método" id="{499b2d92-e6a1-56a2-d05e-f5903b899861}">
+        <p14:section name="Experimento y método" id="{7cd4e0a9-c519-cc62-9370-30486c934777}">
           <p14:sldIdLst>
             <p14:sldId id="257"/>
             <p14:sldId id="258"/>
             <p14:sldId id="259"/>
           </p14:sldIdLst>
         </p14:section>
-        <p14:section name="Chequeo con el cubo macizo" id="{b7f32af3-7238-a01a-5e7f-5801f03d909c}">
+        <p14:section name="Chequeo con el cubo macizo" id="{57288cb3-3026-7802-001c-6758b98112d4}">
           <p14:sldIdLst>
             <p14:sldId id="260"/>
             <p14:sldId id="261"/>
           </p14:sldIdLst>
         </p14:section>
-        <p14:section name="Resultados" id="{e62a197e-5b54-db1f-1938-5d3ace4413b6}">
+        <p14:section name="Resultados" id="{99709caf-b987-8d4b-4f3e-e081e61ee298}">
           <p14:sldIdLst>
             <p14:sldId id="262"/>
             <p14:sldId id="263"/>
@@ -149,7 +149,7 @@
             <p14:sldId id="267"/>
           </p14:sldIdLst>
         </p14:section>
-        <p14:section name="Cierre" id="{143eff25-00e4-b66d-2395-50d9109e334b}">
+        <p14:section name="Cierre" id="{35e2bf47-5b53-db0b-2b8b-8cda02b6c3f2}">
           <p14:sldIdLst>
             <p14:sldId id="268"/>
             <p14:sldId id="269"/>
@@ -1718,7 +1718,7 @@
           <a:p>
             <a:r>
               <a:rPr lang="en-US" dirty="0"/>
-              <a:t>NGSolve con solver directo, misma carga y misma condición de apoyo, remuestreando cada estructura a distintas mallas. Las razones entre estructuras dependen de la resolución; la que se cita a 40 elementos por lado es una primera aproximación, no un valor convergido. El p99 de von Mises del spinodoide sube con la malla porque los puntales finos quedan mejor resueltos.</a:t>
+              <a:t>NGSolve con solver directo, misma carga y misma condición de apoyo, remuestreando cada estructura a distintas mallas. A 80 elementos por lado se usó CG con pyamg (un proceso por caso) por memoria; a 64 coincide con el directo en 4 cifras (comprobado en C2 spinodoide y C3 dual-lattice) y el equilibrio cierra a 10⁻¹³. Las razones entre estructuras dependen de la resolución; la que se cita a 40 elementos por lado es una primera aproximación, no un valor convergido. El p99 de von Mises del spinodoide sube con la malla porque los puntales finos quedan mejor resueltos.</a:t>
             </a:r>
             <a:endParaRPr lang="en-US" dirty="0"/>
           </a:p>
@@ -3850,15 +3850,18 @@
               <a:tblPr/>
               <a:tblGrid>
                 <a:gridCol w="1280160"/>
-                <a:gridCol w="1087120"/>
-                <a:gridCol w="1087120"/>
-                <a:gridCol w="1087120"/>
-                <a:gridCol w="1087120"/>
-                <a:gridCol w="1087120"/>
-                <a:gridCol w="1087120"/>
-                <a:gridCol w="1087120"/>
-                <a:gridCol w="1087120"/>
-                <a:gridCol w="1087120"/>
+                <a:gridCol w="815340"/>
+                <a:gridCol w="815340"/>
+                <a:gridCol w="815340"/>
+                <a:gridCol w="815340"/>
+                <a:gridCol w="815340"/>
+                <a:gridCol w="815340"/>
+                <a:gridCol w="815340"/>
+                <a:gridCol w="815340"/>
+                <a:gridCol w="815340"/>
+                <a:gridCol w="815340"/>
+                <a:gridCol w="815340"/>
+                <a:gridCol w="815340"/>
               </a:tblGrid>
               <a:tr h="384048">
                 <a:tc>
@@ -3929,7 +3932,7 @@
                     </a:solidFill>
                   </a:tcPr>
                 </a:tc>
-                <a:tc gridSpan="3">
+                <a:tc gridSpan="4">
                   <a:txBody>
                     <a:bodyPr/>
                     <a:lstStyle/>
@@ -4003,7 +4006,10 @@
                 <a:tc hMerge="1">
                   <a:tcPr/>
                 </a:tc>
-                <a:tc gridSpan="3">
+                <a:tc hMerge="1">
+                  <a:tcPr/>
+                </a:tc>
+                <a:tc gridSpan="4">
                   <a:txBody>
                     <a:bodyPr/>
                     <a:lstStyle/>
@@ -4077,7 +4083,10 @@
                 <a:tc hMerge="1">
                   <a:tcPr/>
                 </a:tc>
-                <a:tc gridSpan="3">
+                <a:tc hMerge="1">
+                  <a:tcPr/>
+                </a:tc>
+                <a:tc gridSpan="4">
                   <a:txBody>
                     <a:bodyPr/>
                     <a:lstStyle/>
@@ -4144,6 +4153,9 @@
                       <a:srgbClr val="1F3A44"/>
                     </a:solidFill>
                   </a:tcPr>
+                </a:tc>
+                <a:tc hMerge="1">
+                  <a:tcPr/>
                 </a:tc>
                 <a:tc hMerge="1">
                   <a:tcPr/>
@@ -4442,6 +4454,74 @@
                           <a:ea typeface="Calibri" pitchFamily="34" charset="-122"/>
                           <a:cs typeface="Calibri" pitchFamily="34" charset="-120"/>
                         </a:rPr>
+                        <a:t>80</a:t>
+                      </a:r>
+                      <a:endParaRPr lang="en-US" sz="1300" dirty="0">
+                        <a:latin typeface="Calibri" charset="0"/>
+                        <a:ea typeface="Calibri" charset="0"/>
+                        <a:cs typeface="Calibri" charset="0"/>
+                      </a:endParaRPr>
+                    </a:p>
+                  </a:txBody>
+                  <a:tcPr marL="91440" marR="91440" marT="45720" marB="45720" anchor="ctr">
+                    <a:lnL w="12700" cap="flat" cmpd="sng" algn="ctr">
+                      <a:solidFill>
+                        <a:srgbClr val="CFD6D9"/>
+                      </a:solidFill>
+                      <a:prstDash val="solid"/>
+                      <a:round/>
+                      <a:headEnd type="none" w="med" len="med"/>
+                      <a:tailEnd type="none" w="med" len="med"/>
+                    </a:lnL>
+                    <a:lnR w="12700" cap="flat" cmpd="sng" algn="ctr">
+                      <a:solidFill>
+                        <a:srgbClr val="CFD6D9"/>
+                      </a:solidFill>
+                      <a:prstDash val="solid"/>
+                      <a:round/>
+                      <a:headEnd type="none" w="med" len="med"/>
+                      <a:tailEnd type="none" w="med" len="med"/>
+                    </a:lnR>
+                    <a:lnT w="12700" cap="flat" cmpd="sng" algn="ctr">
+                      <a:solidFill>
+                        <a:srgbClr val="CFD6D9"/>
+                      </a:solidFill>
+                      <a:prstDash val="solid"/>
+                      <a:round/>
+                      <a:headEnd type="none" w="med" len="med"/>
+                      <a:tailEnd type="none" w="med" len="med"/>
+                    </a:lnT>
+                    <a:lnB w="12700" cap="flat" cmpd="sng" algn="ctr">
+                      <a:solidFill>
+                        <a:srgbClr val="CFD6D9"/>
+                      </a:solidFill>
+                      <a:prstDash val="solid"/>
+                      <a:round/>
+                      <a:headEnd type="none" w="med" len="med"/>
+                      <a:tailEnd type="none" w="med" len="med"/>
+                    </a:lnB>
+                    <a:solidFill>
+                      <a:srgbClr val="1F3A44"/>
+                    </a:solidFill>
+                  </a:tcPr>
+                </a:tc>
+                <a:tc>
+                  <a:txBody>
+                    <a:bodyPr/>
+                    <a:lstStyle/>
+                    <a:p>
+                      <a:pPr algn="ctr" indent="0" marL="0">
+                        <a:buNone/>
+                      </a:pPr>
+                      <a:r>
+                        <a:rPr lang="en-US" sz="1300" b="1" dirty="0">
+                          <a:solidFill>
+                            <a:srgbClr val="FFFFFF"/>
+                          </a:solidFill>
+                          <a:latin typeface="Calibri" pitchFamily="34" charset="0"/>
+                          <a:ea typeface="Calibri" pitchFamily="34" charset="-122"/>
+                          <a:cs typeface="Calibri" pitchFamily="34" charset="-120"/>
+                        </a:rPr>
                         <a:t>40</a:t>
                       </a:r>
                       <a:endParaRPr lang="en-US" sz="1300" dirty="0">
@@ -4646,6 +4726,74 @@
                           <a:ea typeface="Calibri" pitchFamily="34" charset="-122"/>
                           <a:cs typeface="Calibri" pitchFamily="34" charset="-120"/>
                         </a:rPr>
+                        <a:t>80</a:t>
+                      </a:r>
+                      <a:endParaRPr lang="en-US" sz="1300" dirty="0">
+                        <a:latin typeface="Calibri" charset="0"/>
+                        <a:ea typeface="Calibri" charset="0"/>
+                        <a:cs typeface="Calibri" charset="0"/>
+                      </a:endParaRPr>
+                    </a:p>
+                  </a:txBody>
+                  <a:tcPr marL="91440" marR="91440" marT="45720" marB="45720" anchor="ctr">
+                    <a:lnL w="12700" cap="flat" cmpd="sng" algn="ctr">
+                      <a:solidFill>
+                        <a:srgbClr val="CFD6D9"/>
+                      </a:solidFill>
+                      <a:prstDash val="solid"/>
+                      <a:round/>
+                      <a:headEnd type="none" w="med" len="med"/>
+                      <a:tailEnd type="none" w="med" len="med"/>
+                    </a:lnL>
+                    <a:lnR w="12700" cap="flat" cmpd="sng" algn="ctr">
+                      <a:solidFill>
+                        <a:srgbClr val="CFD6D9"/>
+                      </a:solidFill>
+                      <a:prstDash val="solid"/>
+                      <a:round/>
+                      <a:headEnd type="none" w="med" len="med"/>
+                      <a:tailEnd type="none" w="med" len="med"/>
+                    </a:lnR>
+                    <a:lnT w="12700" cap="flat" cmpd="sng" algn="ctr">
+                      <a:solidFill>
+                        <a:srgbClr val="CFD6D9"/>
+                      </a:solidFill>
+                      <a:prstDash val="solid"/>
+                      <a:round/>
+                      <a:headEnd type="none" w="med" len="med"/>
+                      <a:tailEnd type="none" w="med" len="med"/>
+                    </a:lnT>
+                    <a:lnB w="12700" cap="flat" cmpd="sng" algn="ctr">
+                      <a:solidFill>
+                        <a:srgbClr val="CFD6D9"/>
+                      </a:solidFill>
+                      <a:prstDash val="solid"/>
+                      <a:round/>
+                      <a:headEnd type="none" w="med" len="med"/>
+                      <a:tailEnd type="none" w="med" len="med"/>
+                    </a:lnB>
+                    <a:solidFill>
+                      <a:srgbClr val="1F3A44"/>
+                    </a:solidFill>
+                  </a:tcPr>
+                </a:tc>
+                <a:tc>
+                  <a:txBody>
+                    <a:bodyPr/>
+                    <a:lstStyle/>
+                    <a:p>
+                      <a:pPr algn="ctr" indent="0" marL="0">
+                        <a:buNone/>
+                      </a:pPr>
+                      <a:r>
+                        <a:rPr lang="en-US" sz="1300" b="1" dirty="0">
+                          <a:solidFill>
+                            <a:srgbClr val="FFFFFF"/>
+                          </a:solidFill>
+                          <a:latin typeface="Calibri" pitchFamily="34" charset="0"/>
+                          <a:ea typeface="Calibri" pitchFamily="34" charset="-122"/>
+                          <a:cs typeface="Calibri" pitchFamily="34" charset="-120"/>
+                        </a:rPr>
                         <a:t>40</a:t>
                       </a:r>
                       <a:endParaRPr lang="en-US" sz="1300" dirty="0">
@@ -4783,6 +4931,74 @@
                           <a:cs typeface="Calibri" pitchFamily="34" charset="-120"/>
                         </a:rPr>
                         <a:t>64</a:t>
+                      </a:r>
+                      <a:endParaRPr lang="en-US" sz="1300" dirty="0">
+                        <a:latin typeface="Calibri" charset="0"/>
+                        <a:ea typeface="Calibri" charset="0"/>
+                        <a:cs typeface="Calibri" charset="0"/>
+                      </a:endParaRPr>
+                    </a:p>
+                  </a:txBody>
+                  <a:tcPr marL="91440" marR="91440" marT="45720" marB="45720" anchor="ctr">
+                    <a:lnL w="12700" cap="flat" cmpd="sng" algn="ctr">
+                      <a:solidFill>
+                        <a:srgbClr val="CFD6D9"/>
+                      </a:solidFill>
+                      <a:prstDash val="solid"/>
+                      <a:round/>
+                      <a:headEnd type="none" w="med" len="med"/>
+                      <a:tailEnd type="none" w="med" len="med"/>
+                    </a:lnL>
+                    <a:lnR w="12700" cap="flat" cmpd="sng" algn="ctr">
+                      <a:solidFill>
+                        <a:srgbClr val="CFD6D9"/>
+                      </a:solidFill>
+                      <a:prstDash val="solid"/>
+                      <a:round/>
+                      <a:headEnd type="none" w="med" len="med"/>
+                      <a:tailEnd type="none" w="med" len="med"/>
+                    </a:lnR>
+                    <a:lnT w="12700" cap="flat" cmpd="sng" algn="ctr">
+                      <a:solidFill>
+                        <a:srgbClr val="CFD6D9"/>
+                      </a:solidFill>
+                      <a:prstDash val="solid"/>
+                      <a:round/>
+                      <a:headEnd type="none" w="med" len="med"/>
+                      <a:tailEnd type="none" w="med" len="med"/>
+                    </a:lnT>
+                    <a:lnB w="12700" cap="flat" cmpd="sng" algn="ctr">
+                      <a:solidFill>
+                        <a:srgbClr val="CFD6D9"/>
+                      </a:solidFill>
+                      <a:prstDash val="solid"/>
+                      <a:round/>
+                      <a:headEnd type="none" w="med" len="med"/>
+                      <a:tailEnd type="none" w="med" len="med"/>
+                    </a:lnB>
+                    <a:solidFill>
+                      <a:srgbClr val="1F3A44"/>
+                    </a:solidFill>
+                  </a:tcPr>
+                </a:tc>
+                <a:tc>
+                  <a:txBody>
+                    <a:bodyPr/>
+                    <a:lstStyle/>
+                    <a:p>
+                      <a:pPr algn="ctr" indent="0" marL="0">
+                        <a:buNone/>
+                      </a:pPr>
+                      <a:r>
+                        <a:rPr lang="en-US" sz="1300" b="1" dirty="0">
+                          <a:solidFill>
+                            <a:srgbClr val="FFFFFF"/>
+                          </a:solidFill>
+                          <a:latin typeface="Calibri" pitchFamily="34" charset="0"/>
+                          <a:ea typeface="Calibri" pitchFamily="34" charset="-122"/>
+                          <a:cs typeface="Calibri" pitchFamily="34" charset="-120"/>
+                        </a:rPr>
+                        <a:t>80</a:t>
                       </a:r>
                       <a:endParaRPr lang="en-US" sz="1300" dirty="0">
                         <a:latin typeface="Calibri" charset="0"/>
@@ -5112,6 +5328,71 @@
                           <a:ea typeface="Calibri" pitchFamily="34" charset="-122"/>
                           <a:cs typeface="Calibri" pitchFamily="34" charset="-120"/>
                         </a:rPr>
+                        <a:t>27</a:t>
+                      </a:r>
+                      <a:endParaRPr lang="en-US" sz="1300" dirty="0">
+                        <a:latin typeface="Calibri" charset="0"/>
+                        <a:ea typeface="Calibri" charset="0"/>
+                        <a:cs typeface="Calibri" charset="0"/>
+                      </a:endParaRPr>
+                    </a:p>
+                  </a:txBody>
+                  <a:tcPr marL="91440" marR="91440" marT="45720" marB="45720" anchor="ctr">
+                    <a:lnL w="12700" cap="flat" cmpd="sng" algn="ctr">
+                      <a:solidFill>
+                        <a:srgbClr val="CFD6D9"/>
+                      </a:solidFill>
+                      <a:prstDash val="solid"/>
+                      <a:round/>
+                      <a:headEnd type="none" w="med" len="med"/>
+                      <a:tailEnd type="none" w="med" len="med"/>
+                    </a:lnL>
+                    <a:lnR w="12700" cap="flat" cmpd="sng" algn="ctr">
+                      <a:solidFill>
+                        <a:srgbClr val="CFD6D9"/>
+                      </a:solidFill>
+                      <a:prstDash val="solid"/>
+                      <a:round/>
+                      <a:headEnd type="none" w="med" len="med"/>
+                      <a:tailEnd type="none" w="med" len="med"/>
+                    </a:lnR>
+                    <a:lnT w="12700" cap="flat" cmpd="sng" algn="ctr">
+                      <a:solidFill>
+                        <a:srgbClr val="CFD6D9"/>
+                      </a:solidFill>
+                      <a:prstDash val="solid"/>
+                      <a:round/>
+                      <a:headEnd type="none" w="med" len="med"/>
+                      <a:tailEnd type="none" w="med" len="med"/>
+                    </a:lnT>
+                    <a:lnB w="12700" cap="flat" cmpd="sng" algn="ctr">
+                      <a:solidFill>
+                        <a:srgbClr val="CFD6D9"/>
+                      </a:solidFill>
+                      <a:prstDash val="solid"/>
+                      <a:round/>
+                      <a:headEnd type="none" w="med" len="med"/>
+                      <a:tailEnd type="none" w="med" len="med"/>
+                    </a:lnB>
+                  </a:tcPr>
+                </a:tc>
+                <a:tc>
+                  <a:txBody>
+                    <a:bodyPr/>
+                    <a:lstStyle/>
+                    <a:p>
+                      <a:pPr algn="ctr" indent="0" marL="0">
+                        <a:buNone/>
+                      </a:pPr>
+                      <a:r>
+                        <a:rPr lang="en-US" sz="1300" dirty="0">
+                          <a:solidFill>
+                            <a:srgbClr val="000000"/>
+                          </a:solidFill>
+                          <a:latin typeface="Calibri" pitchFamily="34" charset="0"/>
+                          <a:ea typeface="Calibri" pitchFamily="34" charset="-122"/>
+                          <a:cs typeface="Calibri" pitchFamily="34" charset="-120"/>
+                        </a:rPr>
                         <a:t>75</a:t>
                       </a:r>
                       <a:endParaRPr lang="en-US" sz="1300" dirty="0">
@@ -5307,6 +5588,71 @@
                           <a:ea typeface="Calibri" pitchFamily="34" charset="-122"/>
                           <a:cs typeface="Calibri" pitchFamily="34" charset="-120"/>
                         </a:rPr>
+                        <a:t>71</a:t>
+                      </a:r>
+                      <a:endParaRPr lang="en-US" sz="1300" dirty="0">
+                        <a:latin typeface="Calibri" charset="0"/>
+                        <a:ea typeface="Calibri" charset="0"/>
+                        <a:cs typeface="Calibri" charset="0"/>
+                      </a:endParaRPr>
+                    </a:p>
+                  </a:txBody>
+                  <a:tcPr marL="91440" marR="91440" marT="45720" marB="45720" anchor="ctr">
+                    <a:lnL w="12700" cap="flat" cmpd="sng" algn="ctr">
+                      <a:solidFill>
+                        <a:srgbClr val="CFD6D9"/>
+                      </a:solidFill>
+                      <a:prstDash val="solid"/>
+                      <a:round/>
+                      <a:headEnd type="none" w="med" len="med"/>
+                      <a:tailEnd type="none" w="med" len="med"/>
+                    </a:lnL>
+                    <a:lnR w="12700" cap="flat" cmpd="sng" algn="ctr">
+                      <a:solidFill>
+                        <a:srgbClr val="CFD6D9"/>
+                      </a:solidFill>
+                      <a:prstDash val="solid"/>
+                      <a:round/>
+                      <a:headEnd type="none" w="med" len="med"/>
+                      <a:tailEnd type="none" w="med" len="med"/>
+                    </a:lnR>
+                    <a:lnT w="12700" cap="flat" cmpd="sng" algn="ctr">
+                      <a:solidFill>
+                        <a:srgbClr val="CFD6D9"/>
+                      </a:solidFill>
+                      <a:prstDash val="solid"/>
+                      <a:round/>
+                      <a:headEnd type="none" w="med" len="med"/>
+                      <a:tailEnd type="none" w="med" len="med"/>
+                    </a:lnT>
+                    <a:lnB w="12700" cap="flat" cmpd="sng" algn="ctr">
+                      <a:solidFill>
+                        <a:srgbClr val="CFD6D9"/>
+                      </a:solidFill>
+                      <a:prstDash val="solid"/>
+                      <a:round/>
+                      <a:headEnd type="none" w="med" len="med"/>
+                      <a:tailEnd type="none" w="med" len="med"/>
+                    </a:lnB>
+                  </a:tcPr>
+                </a:tc>
+                <a:tc>
+                  <a:txBody>
+                    <a:bodyPr/>
+                    <a:lstStyle/>
+                    <a:p>
+                      <a:pPr algn="ctr" indent="0" marL="0">
+                        <a:buNone/>
+                      </a:pPr>
+                      <a:r>
+                        <a:rPr lang="en-US" sz="1300" dirty="0">
+                          <a:solidFill>
+                            <a:srgbClr val="000000"/>
+                          </a:solidFill>
+                          <a:latin typeface="Calibri" pitchFamily="34" charset="0"/>
+                          <a:ea typeface="Calibri" pitchFamily="34" charset="-122"/>
+                          <a:cs typeface="Calibri" pitchFamily="34" charset="-120"/>
+                        </a:rPr>
                         <a:t>2,1</a:t>
                       </a:r>
                       <a:endParaRPr lang="en-US" sz="1300" dirty="0">
@@ -5438,6 +5784,71 @@
                           <a:cs typeface="Calibri" pitchFamily="34" charset="-120"/>
                         </a:rPr>
                         <a:t>2,3</a:t>
+                      </a:r>
+                      <a:endParaRPr lang="en-US" sz="1300" dirty="0">
+                        <a:latin typeface="Calibri" charset="0"/>
+                        <a:ea typeface="Calibri" charset="0"/>
+                        <a:cs typeface="Calibri" charset="0"/>
+                      </a:endParaRPr>
+                    </a:p>
+                  </a:txBody>
+                  <a:tcPr marL="91440" marR="91440" marT="45720" marB="45720" anchor="ctr">
+                    <a:lnL w="12700" cap="flat" cmpd="sng" algn="ctr">
+                      <a:solidFill>
+                        <a:srgbClr val="CFD6D9"/>
+                      </a:solidFill>
+                      <a:prstDash val="solid"/>
+                      <a:round/>
+                      <a:headEnd type="none" w="med" len="med"/>
+                      <a:tailEnd type="none" w="med" len="med"/>
+                    </a:lnL>
+                    <a:lnR w="12700" cap="flat" cmpd="sng" algn="ctr">
+                      <a:solidFill>
+                        <a:srgbClr val="CFD6D9"/>
+                      </a:solidFill>
+                      <a:prstDash val="solid"/>
+                      <a:round/>
+                      <a:headEnd type="none" w="med" len="med"/>
+                      <a:tailEnd type="none" w="med" len="med"/>
+                    </a:lnR>
+                    <a:lnT w="12700" cap="flat" cmpd="sng" algn="ctr">
+                      <a:solidFill>
+                        <a:srgbClr val="CFD6D9"/>
+                      </a:solidFill>
+                      <a:prstDash val="solid"/>
+                      <a:round/>
+                      <a:headEnd type="none" w="med" len="med"/>
+                      <a:tailEnd type="none" w="med" len="med"/>
+                    </a:lnT>
+                    <a:lnB w="12700" cap="flat" cmpd="sng" algn="ctr">
+                      <a:solidFill>
+                        <a:srgbClr val="CFD6D9"/>
+                      </a:solidFill>
+                      <a:prstDash val="solid"/>
+                      <a:round/>
+                      <a:headEnd type="none" w="med" len="med"/>
+                      <a:tailEnd type="none" w="med" len="med"/>
+                    </a:lnB>
+                  </a:tcPr>
+                </a:tc>
+                <a:tc>
+                  <a:txBody>
+                    <a:bodyPr/>
+                    <a:lstStyle/>
+                    <a:p>
+                      <a:pPr algn="ctr" indent="0" marL="0">
+                        <a:buNone/>
+                      </a:pPr>
+                      <a:r>
+                        <a:rPr lang="en-US" sz="1300" dirty="0">
+                          <a:solidFill>
+                            <a:srgbClr val="000000"/>
+                          </a:solidFill>
+                          <a:latin typeface="Calibri" pitchFamily="34" charset="0"/>
+                          <a:ea typeface="Calibri" pitchFamily="34" charset="-122"/>
+                          <a:cs typeface="Calibri" pitchFamily="34" charset="-120"/>
+                        </a:rPr>
+                        <a:t>2,4</a:t>
                       </a:r>
                       <a:endParaRPr lang="en-US" sz="1300" dirty="0">
                         <a:latin typeface="Calibri" charset="0"/>
@@ -5764,6 +6175,71 @@
                           <a:ea typeface="Calibri" pitchFamily="34" charset="-122"/>
                           <a:cs typeface="Calibri" pitchFamily="34" charset="-120"/>
                         </a:rPr>
+                        <a:t>13</a:t>
+                      </a:r>
+                      <a:endParaRPr lang="en-US" sz="1300" dirty="0">
+                        <a:latin typeface="Calibri" charset="0"/>
+                        <a:ea typeface="Calibri" charset="0"/>
+                        <a:cs typeface="Calibri" charset="0"/>
+                      </a:endParaRPr>
+                    </a:p>
+                  </a:txBody>
+                  <a:tcPr marL="91440" marR="91440" marT="45720" marB="45720" anchor="ctr">
+                    <a:lnL w="12700" cap="flat" cmpd="sng" algn="ctr">
+                      <a:solidFill>
+                        <a:srgbClr val="CFD6D9"/>
+                      </a:solidFill>
+                      <a:prstDash val="solid"/>
+                      <a:round/>
+                      <a:headEnd type="none" w="med" len="med"/>
+                      <a:tailEnd type="none" w="med" len="med"/>
+                    </a:lnL>
+                    <a:lnR w="12700" cap="flat" cmpd="sng" algn="ctr">
+                      <a:solidFill>
+                        <a:srgbClr val="CFD6D9"/>
+                      </a:solidFill>
+                      <a:prstDash val="solid"/>
+                      <a:round/>
+                      <a:headEnd type="none" w="med" len="med"/>
+                      <a:tailEnd type="none" w="med" len="med"/>
+                    </a:lnR>
+                    <a:lnT w="12700" cap="flat" cmpd="sng" algn="ctr">
+                      <a:solidFill>
+                        <a:srgbClr val="CFD6D9"/>
+                      </a:solidFill>
+                      <a:prstDash val="solid"/>
+                      <a:round/>
+                      <a:headEnd type="none" w="med" len="med"/>
+                      <a:tailEnd type="none" w="med" len="med"/>
+                    </a:lnT>
+                    <a:lnB w="12700" cap="flat" cmpd="sng" algn="ctr">
+                      <a:solidFill>
+                        <a:srgbClr val="CFD6D9"/>
+                      </a:solidFill>
+                      <a:prstDash val="solid"/>
+                      <a:round/>
+                      <a:headEnd type="none" w="med" len="med"/>
+                      <a:tailEnd type="none" w="med" len="med"/>
+                    </a:lnB>
+                  </a:tcPr>
+                </a:tc>
+                <a:tc>
+                  <a:txBody>
+                    <a:bodyPr/>
+                    <a:lstStyle/>
+                    <a:p>
+                      <a:pPr algn="ctr" indent="0" marL="0">
+                        <a:buNone/>
+                      </a:pPr>
+                      <a:r>
+                        <a:rPr lang="en-US" sz="1300" dirty="0">
+                          <a:solidFill>
+                            <a:srgbClr val="000000"/>
+                          </a:solidFill>
+                          <a:latin typeface="Calibri" pitchFamily="34" charset="0"/>
+                          <a:ea typeface="Calibri" pitchFamily="34" charset="-122"/>
+                          <a:cs typeface="Calibri" pitchFamily="34" charset="-120"/>
+                        </a:rPr>
                         <a:t>80</a:t>
                       </a:r>
                       <a:endParaRPr lang="en-US" sz="1300" dirty="0">
@@ -5959,6 +6435,71 @@
                           <a:ea typeface="Calibri" pitchFamily="34" charset="-122"/>
                           <a:cs typeface="Calibri" pitchFamily="34" charset="-120"/>
                         </a:rPr>
+                        <a:t>78</a:t>
+                      </a:r>
+                      <a:endParaRPr lang="en-US" sz="1300" dirty="0">
+                        <a:latin typeface="Calibri" charset="0"/>
+                        <a:ea typeface="Calibri" charset="0"/>
+                        <a:cs typeface="Calibri" charset="0"/>
+                      </a:endParaRPr>
+                    </a:p>
+                  </a:txBody>
+                  <a:tcPr marL="91440" marR="91440" marT="45720" marB="45720" anchor="ctr">
+                    <a:lnL w="12700" cap="flat" cmpd="sng" algn="ctr">
+                      <a:solidFill>
+                        <a:srgbClr val="CFD6D9"/>
+                      </a:solidFill>
+                      <a:prstDash val="solid"/>
+                      <a:round/>
+                      <a:headEnd type="none" w="med" len="med"/>
+                      <a:tailEnd type="none" w="med" len="med"/>
+                    </a:lnL>
+                    <a:lnR w="12700" cap="flat" cmpd="sng" algn="ctr">
+                      <a:solidFill>
+                        <a:srgbClr val="CFD6D9"/>
+                      </a:solidFill>
+                      <a:prstDash val="solid"/>
+                      <a:round/>
+                      <a:headEnd type="none" w="med" len="med"/>
+                      <a:tailEnd type="none" w="med" len="med"/>
+                    </a:lnR>
+                    <a:lnT w="12700" cap="flat" cmpd="sng" algn="ctr">
+                      <a:solidFill>
+                        <a:srgbClr val="CFD6D9"/>
+                      </a:solidFill>
+                      <a:prstDash val="solid"/>
+                      <a:round/>
+                      <a:headEnd type="none" w="med" len="med"/>
+                      <a:tailEnd type="none" w="med" len="med"/>
+                    </a:lnT>
+                    <a:lnB w="12700" cap="flat" cmpd="sng" algn="ctr">
+                      <a:solidFill>
+                        <a:srgbClr val="CFD6D9"/>
+                      </a:solidFill>
+                      <a:prstDash val="solid"/>
+                      <a:round/>
+                      <a:headEnd type="none" w="med" len="med"/>
+                      <a:tailEnd type="none" w="med" len="med"/>
+                    </a:lnB>
+                  </a:tcPr>
+                </a:tc>
+                <a:tc>
+                  <a:txBody>
+                    <a:bodyPr/>
+                    <a:lstStyle/>
+                    <a:p>
+                      <a:pPr algn="ctr" indent="0" marL="0">
+                        <a:buNone/>
+                      </a:pPr>
+                      <a:r>
+                        <a:rPr lang="en-US" sz="1300" dirty="0">
+                          <a:solidFill>
+                            <a:srgbClr val="000000"/>
+                          </a:solidFill>
+                          <a:latin typeface="Calibri" pitchFamily="34" charset="0"/>
+                          <a:ea typeface="Calibri" pitchFamily="34" charset="-122"/>
+                          <a:cs typeface="Calibri" pitchFamily="34" charset="-120"/>
+                        </a:rPr>
                         <a:t>1,8</a:t>
                       </a:r>
                       <a:endParaRPr lang="en-US" sz="1300" dirty="0">
@@ -6090,6 +6631,71 @@
                           <a:cs typeface="Calibri" pitchFamily="34" charset="-120"/>
                         </a:rPr>
                         <a:t>2,0</a:t>
+                      </a:r>
+                      <a:endParaRPr lang="en-US" sz="1300" dirty="0">
+                        <a:latin typeface="Calibri" charset="0"/>
+                        <a:ea typeface="Calibri" charset="0"/>
+                        <a:cs typeface="Calibri" charset="0"/>
+                      </a:endParaRPr>
+                    </a:p>
+                  </a:txBody>
+                  <a:tcPr marL="91440" marR="91440" marT="45720" marB="45720" anchor="ctr">
+                    <a:lnL w="12700" cap="flat" cmpd="sng" algn="ctr">
+                      <a:solidFill>
+                        <a:srgbClr val="CFD6D9"/>
+                      </a:solidFill>
+                      <a:prstDash val="solid"/>
+                      <a:round/>
+                      <a:headEnd type="none" w="med" len="med"/>
+                      <a:tailEnd type="none" w="med" len="med"/>
+                    </a:lnL>
+                    <a:lnR w="12700" cap="flat" cmpd="sng" algn="ctr">
+                      <a:solidFill>
+                        <a:srgbClr val="CFD6D9"/>
+                      </a:solidFill>
+                      <a:prstDash val="solid"/>
+                      <a:round/>
+                      <a:headEnd type="none" w="med" len="med"/>
+                      <a:tailEnd type="none" w="med" len="med"/>
+                    </a:lnR>
+                    <a:lnT w="12700" cap="flat" cmpd="sng" algn="ctr">
+                      <a:solidFill>
+                        <a:srgbClr val="CFD6D9"/>
+                      </a:solidFill>
+                      <a:prstDash val="solid"/>
+                      <a:round/>
+                      <a:headEnd type="none" w="med" len="med"/>
+                      <a:tailEnd type="none" w="med" len="med"/>
+                    </a:lnT>
+                    <a:lnB w="12700" cap="flat" cmpd="sng" algn="ctr">
+                      <a:solidFill>
+                        <a:srgbClr val="CFD6D9"/>
+                      </a:solidFill>
+                      <a:prstDash val="solid"/>
+                      <a:round/>
+                      <a:headEnd type="none" w="med" len="med"/>
+                      <a:tailEnd type="none" w="med" len="med"/>
+                    </a:lnB>
+                  </a:tcPr>
+                </a:tc>
+                <a:tc>
+                  <a:txBody>
+                    <a:bodyPr/>
+                    <a:lstStyle/>
+                    <a:p>
+                      <a:pPr algn="ctr" indent="0" marL="0">
+                        <a:buNone/>
+                      </a:pPr>
+                      <a:r>
+                        <a:rPr lang="en-US" sz="1300" dirty="0">
+                          <a:solidFill>
+                            <a:srgbClr val="000000"/>
+                          </a:solidFill>
+                          <a:latin typeface="Calibri" pitchFamily="34" charset="0"/>
+                          <a:ea typeface="Calibri" pitchFamily="34" charset="-122"/>
+                          <a:cs typeface="Calibri" pitchFamily="34" charset="-120"/>
+                        </a:rPr>
+                        <a:t>2,2</a:t>
                       </a:r>
                       <a:endParaRPr lang="en-US" sz="1300" dirty="0">
                         <a:latin typeface="Calibri" charset="0"/>
@@ -6416,6 +7022,71 @@
                           <a:ea typeface="Calibri" pitchFamily="34" charset="-122"/>
                           <a:cs typeface="Calibri" pitchFamily="34" charset="-120"/>
                         </a:rPr>
+                        <a:t>14</a:t>
+                      </a:r>
+                      <a:endParaRPr lang="en-US" sz="1300" dirty="0">
+                        <a:latin typeface="Calibri" charset="0"/>
+                        <a:ea typeface="Calibri" charset="0"/>
+                        <a:cs typeface="Calibri" charset="0"/>
+                      </a:endParaRPr>
+                    </a:p>
+                  </a:txBody>
+                  <a:tcPr marL="91440" marR="91440" marT="45720" marB="45720" anchor="ctr">
+                    <a:lnL w="12700" cap="flat" cmpd="sng" algn="ctr">
+                      <a:solidFill>
+                        <a:srgbClr val="CFD6D9"/>
+                      </a:solidFill>
+                      <a:prstDash val="solid"/>
+                      <a:round/>
+                      <a:headEnd type="none" w="med" len="med"/>
+                      <a:tailEnd type="none" w="med" len="med"/>
+                    </a:lnL>
+                    <a:lnR w="12700" cap="flat" cmpd="sng" algn="ctr">
+                      <a:solidFill>
+                        <a:srgbClr val="CFD6D9"/>
+                      </a:solidFill>
+                      <a:prstDash val="solid"/>
+                      <a:round/>
+                      <a:headEnd type="none" w="med" len="med"/>
+                      <a:tailEnd type="none" w="med" len="med"/>
+                    </a:lnR>
+                    <a:lnT w="12700" cap="flat" cmpd="sng" algn="ctr">
+                      <a:solidFill>
+                        <a:srgbClr val="CFD6D9"/>
+                      </a:solidFill>
+                      <a:prstDash val="solid"/>
+                      <a:round/>
+                      <a:headEnd type="none" w="med" len="med"/>
+                      <a:tailEnd type="none" w="med" len="med"/>
+                    </a:lnT>
+                    <a:lnB w="12700" cap="flat" cmpd="sng" algn="ctr">
+                      <a:solidFill>
+                        <a:srgbClr val="CFD6D9"/>
+                      </a:solidFill>
+                      <a:prstDash val="solid"/>
+                      <a:round/>
+                      <a:headEnd type="none" w="med" len="med"/>
+                      <a:tailEnd type="none" w="med" len="med"/>
+                    </a:lnB>
+                  </a:tcPr>
+                </a:tc>
+                <a:tc>
+                  <a:txBody>
+                    <a:bodyPr/>
+                    <a:lstStyle/>
+                    <a:p>
+                      <a:pPr algn="ctr" indent="0" marL="0">
+                        <a:buNone/>
+                      </a:pPr>
+                      <a:r>
+                        <a:rPr lang="en-US" sz="1300" dirty="0">
+                          <a:solidFill>
+                            <a:srgbClr val="000000"/>
+                          </a:solidFill>
+                          <a:latin typeface="Calibri" pitchFamily="34" charset="0"/>
+                          <a:ea typeface="Calibri" pitchFamily="34" charset="-122"/>
+                          <a:cs typeface="Calibri" pitchFamily="34" charset="-120"/>
+                        </a:rPr>
                         <a:t>69</a:t>
                       </a:r>
                       <a:endParaRPr lang="en-US" sz="1300" dirty="0">
@@ -6611,6 +7282,71 @@
                           <a:ea typeface="Calibri" pitchFamily="34" charset="-122"/>
                           <a:cs typeface="Calibri" pitchFamily="34" charset="-120"/>
                         </a:rPr>
+                        <a:t>49</a:t>
+                      </a:r>
+                      <a:endParaRPr lang="en-US" sz="1300" dirty="0">
+                        <a:latin typeface="Calibri" charset="0"/>
+                        <a:ea typeface="Calibri" charset="0"/>
+                        <a:cs typeface="Calibri" charset="0"/>
+                      </a:endParaRPr>
+                    </a:p>
+                  </a:txBody>
+                  <a:tcPr marL="91440" marR="91440" marT="45720" marB="45720" anchor="ctr">
+                    <a:lnL w="12700" cap="flat" cmpd="sng" algn="ctr">
+                      <a:solidFill>
+                        <a:srgbClr val="CFD6D9"/>
+                      </a:solidFill>
+                      <a:prstDash val="solid"/>
+                      <a:round/>
+                      <a:headEnd type="none" w="med" len="med"/>
+                      <a:tailEnd type="none" w="med" len="med"/>
+                    </a:lnL>
+                    <a:lnR w="12700" cap="flat" cmpd="sng" algn="ctr">
+                      <a:solidFill>
+                        <a:srgbClr val="CFD6D9"/>
+                      </a:solidFill>
+                      <a:prstDash val="solid"/>
+                      <a:round/>
+                      <a:headEnd type="none" w="med" len="med"/>
+                      <a:tailEnd type="none" w="med" len="med"/>
+                    </a:lnR>
+                    <a:lnT w="12700" cap="flat" cmpd="sng" algn="ctr">
+                      <a:solidFill>
+                        <a:srgbClr val="CFD6D9"/>
+                      </a:solidFill>
+                      <a:prstDash val="solid"/>
+                      <a:round/>
+                      <a:headEnd type="none" w="med" len="med"/>
+                      <a:tailEnd type="none" w="med" len="med"/>
+                    </a:lnT>
+                    <a:lnB w="12700" cap="flat" cmpd="sng" algn="ctr">
+                      <a:solidFill>
+                        <a:srgbClr val="CFD6D9"/>
+                      </a:solidFill>
+                      <a:prstDash val="solid"/>
+                      <a:round/>
+                      <a:headEnd type="none" w="med" len="med"/>
+                      <a:tailEnd type="none" w="med" len="med"/>
+                    </a:lnB>
+                  </a:tcPr>
+                </a:tc>
+                <a:tc>
+                  <a:txBody>
+                    <a:bodyPr/>
+                    <a:lstStyle/>
+                    <a:p>
+                      <a:pPr algn="ctr" indent="0" marL="0">
+                        <a:buNone/>
+                      </a:pPr>
+                      <a:r>
+                        <a:rPr lang="en-US" sz="1300" dirty="0">
+                          <a:solidFill>
+                            <a:srgbClr val="000000"/>
+                          </a:solidFill>
+                          <a:latin typeface="Calibri" pitchFamily="34" charset="0"/>
+                          <a:ea typeface="Calibri" pitchFamily="34" charset="-122"/>
+                          <a:cs typeface="Calibri" pitchFamily="34" charset="-120"/>
+                        </a:rPr>
                         <a:t>3,1</a:t>
                       </a:r>
                       <a:endParaRPr lang="en-US" sz="1300" dirty="0">
@@ -6742,6 +7478,71 @@
                           <a:cs typeface="Calibri" pitchFamily="34" charset="-120"/>
                         </a:rPr>
                         <a:t>3,7</a:t>
+                      </a:r>
+                      <a:endParaRPr lang="en-US" sz="1300" dirty="0">
+                        <a:latin typeface="Calibri" charset="0"/>
+                        <a:ea typeface="Calibri" charset="0"/>
+                        <a:cs typeface="Calibri" charset="0"/>
+                      </a:endParaRPr>
+                    </a:p>
+                  </a:txBody>
+                  <a:tcPr marL="91440" marR="91440" marT="45720" marB="45720" anchor="ctr">
+                    <a:lnL w="12700" cap="flat" cmpd="sng" algn="ctr">
+                      <a:solidFill>
+                        <a:srgbClr val="CFD6D9"/>
+                      </a:solidFill>
+                      <a:prstDash val="solid"/>
+                      <a:round/>
+                      <a:headEnd type="none" w="med" len="med"/>
+                      <a:tailEnd type="none" w="med" len="med"/>
+                    </a:lnL>
+                    <a:lnR w="12700" cap="flat" cmpd="sng" algn="ctr">
+                      <a:solidFill>
+                        <a:srgbClr val="CFD6D9"/>
+                      </a:solidFill>
+                      <a:prstDash val="solid"/>
+                      <a:round/>
+                      <a:headEnd type="none" w="med" len="med"/>
+                      <a:tailEnd type="none" w="med" len="med"/>
+                    </a:lnR>
+                    <a:lnT w="12700" cap="flat" cmpd="sng" algn="ctr">
+                      <a:solidFill>
+                        <a:srgbClr val="CFD6D9"/>
+                      </a:solidFill>
+                      <a:prstDash val="solid"/>
+                      <a:round/>
+                      <a:headEnd type="none" w="med" len="med"/>
+                      <a:tailEnd type="none" w="med" len="med"/>
+                    </a:lnT>
+                    <a:lnB w="12700" cap="flat" cmpd="sng" algn="ctr">
+                      <a:solidFill>
+                        <a:srgbClr val="CFD6D9"/>
+                      </a:solidFill>
+                      <a:prstDash val="solid"/>
+                      <a:round/>
+                      <a:headEnd type="none" w="med" len="med"/>
+                      <a:tailEnd type="none" w="med" len="med"/>
+                    </a:lnB>
+                  </a:tcPr>
+                </a:tc>
+                <a:tc>
+                  <a:txBody>
+                    <a:bodyPr/>
+                    <a:lstStyle/>
+                    <a:p>
+                      <a:pPr algn="ctr" indent="0" marL="0">
+                        <a:buNone/>
+                      </a:pPr>
+                      <a:r>
+                        <a:rPr lang="en-US" sz="1300" dirty="0">
+                          <a:solidFill>
+                            <a:srgbClr val="000000"/>
+                          </a:solidFill>
+                          <a:latin typeface="Calibri" pitchFamily="34" charset="0"/>
+                          <a:ea typeface="Calibri" pitchFamily="34" charset="-122"/>
+                          <a:cs typeface="Calibri" pitchFamily="34" charset="-120"/>
+                        </a:rPr>
+                        <a:t>3,8</a:t>
                       </a:r>
                       <a:endParaRPr lang="en-US" sz="1300" dirty="0">
                         <a:latin typeface="Calibri" charset="0"/>
@@ -7068,6 +7869,71 @@
                           <a:ea typeface="Calibri" pitchFamily="34" charset="-122"/>
                           <a:cs typeface="Calibri" pitchFamily="34" charset="-120"/>
                         </a:rPr>
+                        <a:t>21</a:t>
+                      </a:r>
+                      <a:endParaRPr lang="en-US" sz="1300" dirty="0">
+                        <a:latin typeface="Calibri" charset="0"/>
+                        <a:ea typeface="Calibri" charset="0"/>
+                        <a:cs typeface="Calibri" charset="0"/>
+                      </a:endParaRPr>
+                    </a:p>
+                  </a:txBody>
+                  <a:tcPr marL="91440" marR="91440" marT="45720" marB="45720" anchor="ctr">
+                    <a:lnL w="12700" cap="flat" cmpd="sng" algn="ctr">
+                      <a:solidFill>
+                        <a:srgbClr val="CFD6D9"/>
+                      </a:solidFill>
+                      <a:prstDash val="solid"/>
+                      <a:round/>
+                      <a:headEnd type="none" w="med" len="med"/>
+                      <a:tailEnd type="none" w="med" len="med"/>
+                    </a:lnL>
+                    <a:lnR w="12700" cap="flat" cmpd="sng" algn="ctr">
+                      <a:solidFill>
+                        <a:srgbClr val="CFD6D9"/>
+                      </a:solidFill>
+                      <a:prstDash val="solid"/>
+                      <a:round/>
+                      <a:headEnd type="none" w="med" len="med"/>
+                      <a:tailEnd type="none" w="med" len="med"/>
+                    </a:lnR>
+                    <a:lnT w="12700" cap="flat" cmpd="sng" algn="ctr">
+                      <a:solidFill>
+                        <a:srgbClr val="CFD6D9"/>
+                      </a:solidFill>
+                      <a:prstDash val="solid"/>
+                      <a:round/>
+                      <a:headEnd type="none" w="med" len="med"/>
+                      <a:tailEnd type="none" w="med" len="med"/>
+                    </a:lnT>
+                    <a:lnB w="12700" cap="flat" cmpd="sng" algn="ctr">
+                      <a:solidFill>
+                        <a:srgbClr val="CFD6D9"/>
+                      </a:solidFill>
+                      <a:prstDash val="solid"/>
+                      <a:round/>
+                      <a:headEnd type="none" w="med" len="med"/>
+                      <a:tailEnd type="none" w="med" len="med"/>
+                    </a:lnB>
+                  </a:tcPr>
+                </a:tc>
+                <a:tc>
+                  <a:txBody>
+                    <a:bodyPr/>
+                    <a:lstStyle/>
+                    <a:p>
+                      <a:pPr algn="ctr" indent="0" marL="0">
+                        <a:buNone/>
+                      </a:pPr>
+                      <a:r>
+                        <a:rPr lang="en-US" sz="1300" dirty="0">
+                          <a:solidFill>
+                            <a:srgbClr val="000000"/>
+                          </a:solidFill>
+                          <a:latin typeface="Calibri" pitchFamily="34" charset="0"/>
+                          <a:ea typeface="Calibri" pitchFamily="34" charset="-122"/>
+                          <a:cs typeface="Calibri" pitchFamily="34" charset="-120"/>
+                        </a:rPr>
                         <a:t>79</a:t>
                       </a:r>
                       <a:endParaRPr lang="en-US" sz="1300" dirty="0">
@@ -7263,6 +8129,71 @@
                           <a:ea typeface="Calibri" pitchFamily="34" charset="-122"/>
                           <a:cs typeface="Calibri" pitchFamily="34" charset="-120"/>
                         </a:rPr>
+                        <a:t>69</a:t>
+                      </a:r>
+                      <a:endParaRPr lang="en-US" sz="1300" dirty="0">
+                        <a:latin typeface="Calibri" charset="0"/>
+                        <a:ea typeface="Calibri" charset="0"/>
+                        <a:cs typeface="Calibri" charset="0"/>
+                      </a:endParaRPr>
+                    </a:p>
+                  </a:txBody>
+                  <a:tcPr marL="91440" marR="91440" marT="45720" marB="45720" anchor="ctr">
+                    <a:lnL w="12700" cap="flat" cmpd="sng" algn="ctr">
+                      <a:solidFill>
+                        <a:srgbClr val="CFD6D9"/>
+                      </a:solidFill>
+                      <a:prstDash val="solid"/>
+                      <a:round/>
+                      <a:headEnd type="none" w="med" len="med"/>
+                      <a:tailEnd type="none" w="med" len="med"/>
+                    </a:lnL>
+                    <a:lnR w="12700" cap="flat" cmpd="sng" algn="ctr">
+                      <a:solidFill>
+                        <a:srgbClr val="CFD6D9"/>
+                      </a:solidFill>
+                      <a:prstDash val="solid"/>
+                      <a:round/>
+                      <a:headEnd type="none" w="med" len="med"/>
+                      <a:tailEnd type="none" w="med" len="med"/>
+                    </a:lnR>
+                    <a:lnT w="12700" cap="flat" cmpd="sng" algn="ctr">
+                      <a:solidFill>
+                        <a:srgbClr val="CFD6D9"/>
+                      </a:solidFill>
+                      <a:prstDash val="solid"/>
+                      <a:round/>
+                      <a:headEnd type="none" w="med" len="med"/>
+                      <a:tailEnd type="none" w="med" len="med"/>
+                    </a:lnT>
+                    <a:lnB w="12700" cap="flat" cmpd="sng" algn="ctr">
+                      <a:solidFill>
+                        <a:srgbClr val="CFD6D9"/>
+                      </a:solidFill>
+                      <a:prstDash val="solid"/>
+                      <a:round/>
+                      <a:headEnd type="none" w="med" len="med"/>
+                      <a:tailEnd type="none" w="med" len="med"/>
+                    </a:lnB>
+                  </a:tcPr>
+                </a:tc>
+                <a:tc>
+                  <a:txBody>
+                    <a:bodyPr/>
+                    <a:lstStyle/>
+                    <a:p>
+                      <a:pPr algn="ctr" indent="0" marL="0">
+                        <a:buNone/>
+                      </a:pPr>
+                      <a:r>
+                        <a:rPr lang="en-US" sz="1300" dirty="0">
+                          <a:solidFill>
+                            <a:srgbClr val="000000"/>
+                          </a:solidFill>
+                          <a:latin typeface="Calibri" pitchFamily="34" charset="0"/>
+                          <a:ea typeface="Calibri" pitchFamily="34" charset="-122"/>
+                          <a:cs typeface="Calibri" pitchFamily="34" charset="-120"/>
+                        </a:rPr>
                         <a:t>2,5</a:t>
                       </a:r>
                       <a:endParaRPr lang="en-US" sz="1300" dirty="0">
@@ -7394,6 +8325,71 @@
                           <a:cs typeface="Calibri" pitchFamily="34" charset="-120"/>
                         </a:rPr>
                         <a:t>2,9</a:t>
+                      </a:r>
+                      <a:endParaRPr lang="en-US" sz="1300" dirty="0">
+                        <a:latin typeface="Calibri" charset="0"/>
+                        <a:ea typeface="Calibri" charset="0"/>
+                        <a:cs typeface="Calibri" charset="0"/>
+                      </a:endParaRPr>
+                    </a:p>
+                  </a:txBody>
+                  <a:tcPr marL="91440" marR="91440" marT="45720" marB="45720" anchor="ctr">
+                    <a:lnL w="12700" cap="flat" cmpd="sng" algn="ctr">
+                      <a:solidFill>
+                        <a:srgbClr val="CFD6D9"/>
+                      </a:solidFill>
+                      <a:prstDash val="solid"/>
+                      <a:round/>
+                      <a:headEnd type="none" w="med" len="med"/>
+                      <a:tailEnd type="none" w="med" len="med"/>
+                    </a:lnL>
+                    <a:lnR w="12700" cap="flat" cmpd="sng" algn="ctr">
+                      <a:solidFill>
+                        <a:srgbClr val="CFD6D9"/>
+                      </a:solidFill>
+                      <a:prstDash val="solid"/>
+                      <a:round/>
+                      <a:headEnd type="none" w="med" len="med"/>
+                      <a:tailEnd type="none" w="med" len="med"/>
+                    </a:lnR>
+                    <a:lnT w="12700" cap="flat" cmpd="sng" algn="ctr">
+                      <a:solidFill>
+                        <a:srgbClr val="CFD6D9"/>
+                      </a:solidFill>
+                      <a:prstDash val="solid"/>
+                      <a:round/>
+                      <a:headEnd type="none" w="med" len="med"/>
+                      <a:tailEnd type="none" w="med" len="med"/>
+                    </a:lnT>
+                    <a:lnB w="12700" cap="flat" cmpd="sng" algn="ctr">
+                      <a:solidFill>
+                        <a:srgbClr val="CFD6D9"/>
+                      </a:solidFill>
+                      <a:prstDash val="solid"/>
+                      <a:round/>
+                      <a:headEnd type="none" w="med" len="med"/>
+                      <a:tailEnd type="none" w="med" len="med"/>
+                    </a:lnB>
+                  </a:tcPr>
+                </a:tc>
+                <a:tc>
+                  <a:txBody>
+                    <a:bodyPr/>
+                    <a:lstStyle/>
+                    <a:p>
+                      <a:pPr algn="ctr" indent="0" marL="0">
+                        <a:buNone/>
+                      </a:pPr>
+                      <a:r>
+                        <a:rPr lang="en-US" sz="1300" dirty="0">
+                          <a:solidFill>
+                            <a:srgbClr val="000000"/>
+                          </a:solidFill>
+                          <a:latin typeface="Calibri" pitchFamily="34" charset="0"/>
+                          <a:ea typeface="Calibri" pitchFamily="34" charset="-122"/>
+                          <a:cs typeface="Calibri" pitchFamily="34" charset="-120"/>
+                        </a:rPr>
+                        <a:t>3,1</a:t>
                       </a:r>
                       <a:endParaRPr lang="en-US" sz="1300" dirty="0">
                         <a:latin typeface="Calibri" charset="0"/>
@@ -7720,7 +8716,7 @@
                           <a:ea typeface="Calibri" pitchFamily="34" charset="-122"/>
                           <a:cs typeface="Calibri" pitchFamily="34" charset="-120"/>
                         </a:rPr>
-                        <a:t>75</a:t>
+                        <a:t>41</a:t>
                       </a:r>
                       <a:endParaRPr lang="en-US" sz="1300" dirty="0">
                         <a:latin typeface="Calibri" charset="0"/>
@@ -7850,7 +8846,137 @@
                           <a:ea typeface="Calibri" pitchFamily="34" charset="-122"/>
                           <a:cs typeface="Calibri" pitchFamily="34" charset="-120"/>
                         </a:rPr>
+                        <a:t>75</a:t>
+                      </a:r>
+                      <a:endParaRPr lang="en-US" sz="1300" dirty="0">
+                        <a:latin typeface="Calibri" charset="0"/>
+                        <a:ea typeface="Calibri" charset="0"/>
+                        <a:cs typeface="Calibri" charset="0"/>
+                      </a:endParaRPr>
+                    </a:p>
+                  </a:txBody>
+                  <a:tcPr marL="91440" marR="91440" marT="45720" marB="45720" anchor="ctr">
+                    <a:lnL w="12700" cap="flat" cmpd="sng" algn="ctr">
+                      <a:solidFill>
+                        <a:srgbClr val="CFD6D9"/>
+                      </a:solidFill>
+                      <a:prstDash val="solid"/>
+                      <a:round/>
+                      <a:headEnd type="none" w="med" len="med"/>
+                      <a:tailEnd type="none" w="med" len="med"/>
+                    </a:lnL>
+                    <a:lnR w="12700" cap="flat" cmpd="sng" algn="ctr">
+                      <a:solidFill>
+                        <a:srgbClr val="CFD6D9"/>
+                      </a:solidFill>
+                      <a:prstDash val="solid"/>
+                      <a:round/>
+                      <a:headEnd type="none" w="med" len="med"/>
+                      <a:tailEnd type="none" w="med" len="med"/>
+                    </a:lnR>
+                    <a:lnT w="12700" cap="flat" cmpd="sng" algn="ctr">
+                      <a:solidFill>
+                        <a:srgbClr val="CFD6D9"/>
+                      </a:solidFill>
+                      <a:prstDash val="solid"/>
+                      <a:round/>
+                      <a:headEnd type="none" w="med" len="med"/>
+                      <a:tailEnd type="none" w="med" len="med"/>
+                    </a:lnT>
+                    <a:lnB w="12700" cap="flat" cmpd="sng" algn="ctr">
+                      <a:solidFill>
+                        <a:srgbClr val="CFD6D9"/>
+                      </a:solidFill>
+                      <a:prstDash val="solid"/>
+                      <a:round/>
+                      <a:headEnd type="none" w="med" len="med"/>
+                      <a:tailEnd type="none" w="med" len="med"/>
+                    </a:lnB>
+                  </a:tcPr>
+                </a:tc>
+                <a:tc>
+                  <a:txBody>
+                    <a:bodyPr/>
+                    <a:lstStyle/>
+                    <a:p>
+                      <a:pPr algn="ctr" indent="0" marL="0">
+                        <a:buNone/>
+                      </a:pPr>
+                      <a:r>
+                        <a:rPr lang="en-US" sz="1300" dirty="0">
+                          <a:solidFill>
+                            <a:srgbClr val="000000"/>
+                          </a:solidFill>
+                          <a:latin typeface="Calibri" pitchFamily="34" charset="0"/>
+                          <a:ea typeface="Calibri" pitchFamily="34" charset="-122"/>
+                          <a:cs typeface="Calibri" pitchFamily="34" charset="-120"/>
+                        </a:rPr>
                         <a:t>74</a:t>
+                      </a:r>
+                      <a:endParaRPr lang="en-US" sz="1300" dirty="0">
+                        <a:latin typeface="Calibri" charset="0"/>
+                        <a:ea typeface="Calibri" charset="0"/>
+                        <a:cs typeface="Calibri" charset="0"/>
+                      </a:endParaRPr>
+                    </a:p>
+                  </a:txBody>
+                  <a:tcPr marL="91440" marR="91440" marT="45720" marB="45720" anchor="ctr">
+                    <a:lnL w="12700" cap="flat" cmpd="sng" algn="ctr">
+                      <a:solidFill>
+                        <a:srgbClr val="CFD6D9"/>
+                      </a:solidFill>
+                      <a:prstDash val="solid"/>
+                      <a:round/>
+                      <a:headEnd type="none" w="med" len="med"/>
+                      <a:tailEnd type="none" w="med" len="med"/>
+                    </a:lnL>
+                    <a:lnR w="12700" cap="flat" cmpd="sng" algn="ctr">
+                      <a:solidFill>
+                        <a:srgbClr val="CFD6D9"/>
+                      </a:solidFill>
+                      <a:prstDash val="solid"/>
+                      <a:round/>
+                      <a:headEnd type="none" w="med" len="med"/>
+                      <a:tailEnd type="none" w="med" len="med"/>
+                    </a:lnR>
+                    <a:lnT w="12700" cap="flat" cmpd="sng" algn="ctr">
+                      <a:solidFill>
+                        <a:srgbClr val="CFD6D9"/>
+                      </a:solidFill>
+                      <a:prstDash val="solid"/>
+                      <a:round/>
+                      <a:headEnd type="none" w="med" len="med"/>
+                      <a:tailEnd type="none" w="med" len="med"/>
+                    </a:lnT>
+                    <a:lnB w="12700" cap="flat" cmpd="sng" algn="ctr">
+                      <a:solidFill>
+                        <a:srgbClr val="CFD6D9"/>
+                      </a:solidFill>
+                      <a:prstDash val="solid"/>
+                      <a:round/>
+                      <a:headEnd type="none" w="med" len="med"/>
+                      <a:tailEnd type="none" w="med" len="med"/>
+                    </a:lnB>
+                  </a:tcPr>
+                </a:tc>
+                <a:tc>
+                  <a:txBody>
+                    <a:bodyPr/>
+                    <a:lstStyle/>
+                    <a:p>
+                      <a:pPr algn="ctr" indent="0" marL="0">
+                        <a:buNone/>
+                      </a:pPr>
+                      <a:r>
+                        <a:rPr lang="en-US" sz="1300" dirty="0">
+                          <a:solidFill>
+                            <a:srgbClr val="000000"/>
+                          </a:solidFill>
+                          <a:latin typeface="Calibri" pitchFamily="34" charset="0"/>
+                          <a:ea typeface="Calibri" pitchFamily="34" charset="-122"/>
+                          <a:cs typeface="Calibri" pitchFamily="34" charset="-120"/>
+                        </a:rPr>
+                        <a:t>73</a:t>
                       </a:r>
                       <a:endParaRPr lang="en-US" sz="1300" dirty="0">
                         <a:latin typeface="Calibri" charset="0"/>
@@ -7981,6 +9107,71 @@
                           <a:cs typeface="Calibri" pitchFamily="34" charset="-120"/>
                         </a:rPr>
                         <a:t>2,2</a:t>
+                      </a:r>
+                      <a:endParaRPr lang="en-US" sz="1300" dirty="0">
+                        <a:latin typeface="Calibri" charset="0"/>
+                        <a:ea typeface="Calibri" charset="0"/>
+                        <a:cs typeface="Calibri" charset="0"/>
+                      </a:endParaRPr>
+                    </a:p>
+                  </a:txBody>
+                  <a:tcPr marL="91440" marR="91440" marT="45720" marB="45720" anchor="ctr">
+                    <a:lnL w="12700" cap="flat" cmpd="sng" algn="ctr">
+                      <a:solidFill>
+                        <a:srgbClr val="CFD6D9"/>
+                      </a:solidFill>
+                      <a:prstDash val="solid"/>
+                      <a:round/>
+                      <a:headEnd type="none" w="med" len="med"/>
+                      <a:tailEnd type="none" w="med" len="med"/>
+                    </a:lnL>
+                    <a:lnR w="12700" cap="flat" cmpd="sng" algn="ctr">
+                      <a:solidFill>
+                        <a:srgbClr val="CFD6D9"/>
+                      </a:solidFill>
+                      <a:prstDash val="solid"/>
+                      <a:round/>
+                      <a:headEnd type="none" w="med" len="med"/>
+                      <a:tailEnd type="none" w="med" len="med"/>
+                    </a:lnR>
+                    <a:lnT w="12700" cap="flat" cmpd="sng" algn="ctr">
+                      <a:solidFill>
+                        <a:srgbClr val="CFD6D9"/>
+                      </a:solidFill>
+                      <a:prstDash val="solid"/>
+                      <a:round/>
+                      <a:headEnd type="none" w="med" len="med"/>
+                      <a:tailEnd type="none" w="med" len="med"/>
+                    </a:lnT>
+                    <a:lnB w="12700" cap="flat" cmpd="sng" algn="ctr">
+                      <a:solidFill>
+                        <a:srgbClr val="CFD6D9"/>
+                      </a:solidFill>
+                      <a:prstDash val="solid"/>
+                      <a:round/>
+                      <a:headEnd type="none" w="med" len="med"/>
+                      <a:tailEnd type="none" w="med" len="med"/>
+                    </a:lnB>
+                  </a:tcPr>
+                </a:tc>
+                <a:tc>
+                  <a:txBody>
+                    <a:bodyPr/>
+                    <a:lstStyle/>
+                    <a:p>
+                      <a:pPr algn="ctr" indent="0" marL="0">
+                        <a:buNone/>
+                      </a:pPr>
+                      <a:r>
+                        <a:rPr lang="en-US" sz="1300" dirty="0">
+                          <a:solidFill>
+                            <a:srgbClr val="000000"/>
+                          </a:solidFill>
+                          <a:latin typeface="Calibri" pitchFamily="34" charset="0"/>
+                          <a:ea typeface="Calibri" pitchFamily="34" charset="-122"/>
+                          <a:cs typeface="Calibri" pitchFamily="34" charset="-120"/>
+                        </a:rPr>
+                        <a:t>2,1</a:t>
                       </a:r>
                       <a:endParaRPr lang="en-US" sz="1300" dirty="0">
                         <a:latin typeface="Calibri" charset="0"/>
@@ -8158,7 +9349,7 @@
                 <a:ea typeface="Cambria" pitchFamily="34" charset="-122"/>
                 <a:cs typeface="Cambria" pitchFamily="34" charset="-120"/>
               </a:rPr>
-              <a:t>2 %</a:t>
+              <a:t>3 %</a:t>
             </a:r>
             <a:endParaRPr lang="en-US" sz="3200" dirty="0"/>
           </a:p>
@@ -8197,7 +9388,7 @@
                 <a:ea typeface="Calibri" pitchFamily="34" charset="-122"/>
                 <a:cs typeface="Calibri" pitchFamily="34" charset="-120"/>
               </a:rPr>
-              <a:t>cambio máximo de E_app del VOI entre 40³ y 64³: converge razonablemente</a:t>
+              <a:t>cambio máximo de E_app del VOI entre 40³ y 80³: converge razonablemente</a:t>
             </a:r>
             <a:endParaRPr lang="en-US" sz="1300" dirty="0"/>
           </a:p>
@@ -8263,7 +9454,7 @@
                 <a:ea typeface="Cambria" pitchFamily="34" charset="-122"/>
                 <a:cs typeface="Cambria" pitchFamily="34" charset="-120"/>
               </a:rPr>
-              <a:t>28 %</a:t>
+              <a:t>65 %</a:t>
             </a:r>
             <a:endParaRPr lang="en-US" sz="3200" dirty="0"/>
           </a:p>
@@ -8302,7 +9493,7 @@
                 <a:ea typeface="Calibri" pitchFamily="34" charset="-122"/>
                 <a:cs typeface="Calibri" pitchFamily="34" charset="-120"/>
               </a:rPr>
-              <a:t>cambio máximo en el spinodoide: sus puntales finos siguen resolviéndose, la malla no ha convergido</a:t>
+              <a:t>cambio máximo de E_app del spinodoide entre 64³ y 80³ (dual-lattice: 25 %): no han convergido y hay saltos bruscos</a:t>
             </a:r>
             <a:endParaRPr lang="en-US" sz="1300" dirty="0"/>
           </a:p>
@@ -8407,7 +9598,7 @@
                 <a:ea typeface="Calibri" pitchFamily="34" charset="-122"/>
                 <a:cs typeface="Calibri" pitchFamily="34" charset="-120"/>
               </a:rPr>
-              <a:t>VOI &gt; dual-lattice &gt; spinodoide se conserva en cada malla (salvo C5, donde dual y spinodoide quedan cercanos)</a:t>
+              <a:t>VOI &gt; dual-lattice &gt; spinodoide se conserva en los 5 VOIs y en todas las mallas. A 80³ el spinodoide conserva 13 a 41 % y el dual-lattice 49 a 78 %</a:t>
             </a:r>
             <a:endParaRPr lang="en-US" sz="1300" dirty="0"/>
           </a:p>

</xml_diff>